<commit_message>
Sesión 2: pendientes de la sesión 1, charla de receso y anexo visual
- La sesión 2 absorbe lo que quedó pendiente de la sesión 1 (trazabilidad,
  enmascaramiento y justificación técnica); la ficha de idoneidad se
  entrega el jueves 17 antes de las 9:00.
- Charla opcional en el receso y anexo visual "De la regresión al
  transformer" en sesion-01, pedido por los participantes.
- Relojes de los ejercicios ajustados a sus bloques de agenda; el cierre
  forma los equipos para el Laboratorio 1.
- Sesión 1: se retira una lámina duplicada y un pendiente de edición.

Co-Authored-By: Claude Fable 5 <noreply@anthropic.com>
</commit_message>
<xml_diff>
--- a/sesion-01/Sesion_01_Introduccion_IA_Generativa.pptx
+++ b/sesion-01/Sesion_01_Introduccion_IA_Generativa.pptx
@@ -14,7 +14,6 @@
     <p:sldId id="259" r:id="rId7"/>
     <p:sldId id="260" r:id="rId8"/>
     <p:sldId id="261" r:id="rId9"/>
-    <p:sldId id="262" r:id="rId10"/>
     <p:sldId id="263" r:id="rId11"/>
     <p:sldId id="264" r:id="rId12"/>
     <p:sldId id="265" r:id="rId13"/>
@@ -6422,167 +6421,6 @@
 </p:notes>
 </file>
 
-<file path=ppt/notesSlides/notesSlide7.xml><?xml version="1.0" encoding="utf-8"?>
-<p:notes xmlns:a="http://schemas.openxmlformats.org/drawingml/2006/main" xmlns:p="http://schemas.openxmlformats.org/presentationml/2006/main" xmlns:r="http://schemas.openxmlformats.org/officeDocument/2006/relationships" xmlns:p14="http://schemas.microsoft.com/office/powerpoint/2010/main" xmlns:p15="http://schemas.microsoft.com/office/powerpoint/2012/main" xmlns:mc="http://schemas.openxmlformats.org/markup-compatibility/2006">
-  <p:cSld>
-    <p:spTree>
-      <p:nvGrpSpPr>
-        <p:cNvPr id="1" name=""/>
-        <p:cNvGrpSpPr/>
-        <p:nvPr/>
-      </p:nvGrpSpPr>
-      <p:grpSpPr>
-        <a:xfrm>
-          <a:off x="0" y="0"/>
-          <a:ext cx="0" cy="0"/>
-          <a:chOff x="0" y="0"/>
-          <a:chExt cx="0" cy="0"/>
-        </a:xfrm>
-      </p:grpSpPr>
-      <p:sp>
-        <p:nvSpPr>
-          <p:cNvPr id="695" name="PlaceHolder 1"/>
-          <p:cNvSpPr>
-            <a:spLocks noGrp="1"/>
-          </p:cNvSpPr>
-          <p:nvPr>
-            <p:ph type="sldImg"/>
-          </p:nvPr>
-        </p:nvSpPr>
-        <p:spPr>
-          <a:xfrm>
-            <a:off x="685800" y="1143000"/>
-            <a:ext cx="5486040" cy="3085920"/>
-          </a:xfrm>
-          <a:prstGeom prst="rect">
-            <a:avLst/>
-          </a:prstGeom>
-          <a:ln w="0">
-            <a:noFill/>
-          </a:ln>
-        </p:spPr>
-      </p:sp>
-      <p:sp>
-        <p:nvSpPr>
-          <p:cNvPr id="696" name="PlaceHolder 2"/>
-          <p:cNvSpPr>
-            <a:spLocks noGrp="1"/>
-          </p:cNvSpPr>
-          <p:nvPr>
-            <p:ph type="body"/>
-          </p:nvPr>
-        </p:nvSpPr>
-        <p:spPr>
-          <a:xfrm>
-            <a:off x="685800" y="4400640"/>
-            <a:ext cx="5486040" cy="3600000"/>
-          </a:xfrm>
-          <a:prstGeom prst="rect">
-            <a:avLst/>
-          </a:prstGeom>
-          <a:noFill/>
-          <a:ln w="0">
-            <a:noFill/>
-          </a:ln>
-        </p:spPr>
-        <p:txBody>
-          <a:bodyPr lIns="91440" tIns="45720" rIns="91440" bIns="45720" anchor="t">
-            <a:noAutofit/>
-          </a:bodyPr>
-          <a:p>
-            <a:pPr indent="0" algn="l">
-              <a:buNone/>
-            </a:pPr>
-            <a:endParaRPr lang="en-US" sz="1800" b="0" u="none" strike="noStrike">
-              <a:solidFill>
-                <a:srgbClr val="000000"/>
-              </a:solidFill>
-              <a:effectLst/>
-              <a:uFillTx/>
-              <a:latin typeface="Arial"/>
-            </a:endParaRPr>
-          </a:p>
-        </p:txBody>
-      </p:sp>
-      <p:sp>
-        <p:nvSpPr>
-          <p:cNvPr id="697" name="PlaceHolder 3"/>
-          <p:cNvSpPr>
-            <a:spLocks noGrp="1"/>
-          </p:cNvSpPr>
-          <p:nvPr>
-            <p:ph type="sldNum" idx="10"/>
-          </p:nvPr>
-        </p:nvSpPr>
-        <p:spPr>
-          <a:xfrm>
-            <a:off x="3884760" y="8685360"/>
-            <a:ext cx="2971440" cy="458280"/>
-          </a:xfrm>
-          <a:prstGeom prst="rect">
-            <a:avLst/>
-          </a:prstGeom>
-          <a:noFill/>
-          <a:ln w="0">
-            <a:noFill/>
-          </a:ln>
-        </p:spPr>
-        <p:txBody>
-          <a:bodyPr lIns="91440" tIns="45720" rIns="91440" bIns="45720" anchor="b">
-            <a:noAutofit/>
-          </a:bodyPr>
-          <a:lstStyle>
-            <a:lvl1pPr indent="0" algn="r" defTabSz="914400">
-              <a:lnSpc>
-                <a:spcPct val="100000"/>
-              </a:lnSpc>
-              <a:buNone/>
-              <a:defRPr lang="en-US" sz="1200" b="0" u="none" strike="noStrike">
-                <a:solidFill>
-                  <a:schemeClr val="dk1"/>
-                </a:solidFill>
-                <a:effectLst/>
-                <a:uFillTx/>
-                <a:latin typeface="+mn-lt"/>
-                <a:ea typeface="+mn-ea"/>
-              </a:defRPr>
-            </a:lvl1pPr>
-          </a:lstStyle>
-          <a:p>
-            <a:pPr indent="0" algn="r" defTabSz="914400">
-              <a:lnSpc>
-                <a:spcPct val="100000"/>
-              </a:lnSpc>
-              <a:buNone/>
-            </a:pPr>
-            <a:fld id="{14A38ED6-9BFA-4F6E-BA4B-C685385692A9}" type="slidenum">
-              <a:rPr lang="en-US" sz="1200" b="0" u="none" strike="noStrike">
-                <a:solidFill>
-                  <a:schemeClr val="dk1"/>
-                </a:solidFill>
-                <a:effectLst/>
-                <a:uFillTx/>
-                <a:latin typeface="+mn-lt"/>
-                <a:ea typeface="+mn-ea"/>
-              </a:rPr>
-              <a:t>1</a:t>
-            </a:fld>
-            <a:endParaRPr lang="en-US" sz="1200" b="0" u="none" strike="noStrike">
-              <a:solidFill>
-                <a:srgbClr val="000000"/>
-              </a:solidFill>
-              <a:effectLst/>
-              <a:uFillTx/>
-              <a:latin typeface="Times New Roman"/>
-            </a:endParaRPr>
-          </a:p>
-        </p:txBody>
-      </p:sp>
-    </p:spTree>
-  </p:cSld>
-</p:notes>
-</file>
-
 <file path=ppt/notesSlides/notesSlide8.xml><?xml version="1.0" encoding="utf-8"?>
 <p:notes xmlns:a="http://schemas.openxmlformats.org/drawingml/2006/main" xmlns:p="http://schemas.openxmlformats.org/presentationml/2006/main" xmlns:r="http://schemas.openxmlformats.org/officeDocument/2006/relationships" xmlns:p14="http://schemas.microsoft.com/office/powerpoint/2010/main" xmlns:p15="http://schemas.microsoft.com/office/powerpoint/2012/main" xmlns:mc="http://schemas.openxmlformats.org/markup-compatibility/2006">
   <p:cSld>
@@ -19970,115 +19808,6 @@
           </a:p>
         </p:txBody>
       </p:sp>
-      <p:sp>
-        <p:nvSpPr>
-          <p:cNvPr id="28" name="Shape 14"/>
-          <p:cNvSpPr/>
-          <p:nvPr/>
-        </p:nvSpPr>
-        <p:spPr>
-          <a:xfrm>
-            <a:off x="567000" y="5998320"/>
-            <a:ext cx="11057400" cy="456840"/>
-          </a:xfrm>
-          <a:prstGeom prst="roundRect">
-            <a:avLst>
-              <a:gd name="adj" fmla="val 12000"/>
-            </a:avLst>
-          </a:prstGeom>
-          <a:solidFill>
-            <a:srgbClr val="F7E4D8"/>
-          </a:solidFill>
-          <a:ln w="12700">
-            <a:solidFill>
-              <a:srgbClr val="F7E4D8"/>
-            </a:solidFill>
-            <a:round/>
-          </a:ln>
-        </p:spPr>
-        <p:style>
-          <a:lnRef idx="0"/>
-          <a:fillRef idx="0"/>
-          <a:effectRef idx="0"/>
-          <a:fontRef idx="minor"/>
-        </p:style>
-        <p:txBody>
-          <a:bodyPr lIns="90000" tIns="45000" rIns="90000" bIns="45000" anchor="t">
-            <a:noAutofit/>
-          </a:bodyPr>
-          <a:p>
-            <a:endParaRPr lang="en-US" sz="1800" b="0" u="none" strike="noStrike">
-              <a:solidFill>
-                <a:srgbClr val="000000"/>
-              </a:solidFill>
-              <a:effectLst/>
-              <a:uFillTx/>
-              <a:latin typeface="Arial"/>
-            </a:endParaRPr>
-          </a:p>
-        </p:txBody>
-      </p:sp>
-      <p:sp>
-        <p:nvSpPr>
-          <p:cNvPr id="29" name="Text 15"/>
-          <p:cNvSpPr/>
-          <p:nvPr/>
-        </p:nvSpPr>
-        <p:spPr>
-          <a:xfrm>
-            <a:off x="786240" y="5998320"/>
-            <a:ext cx="10618560" cy="456840"/>
-          </a:xfrm>
-          <a:prstGeom prst="rect">
-            <a:avLst/>
-          </a:prstGeom>
-          <a:noFill/>
-          <a:ln w="0">
-            <a:noFill/>
-          </a:ln>
-        </p:spPr>
-        <p:style>
-          <a:lnRef idx="0"/>
-          <a:fillRef idx="0"/>
-          <a:effectRef idx="0"/>
-          <a:fontRef idx="minor"/>
-        </p:style>
-        <p:txBody>
-          <a:bodyPr lIns="0" tIns="0" rIns="0" bIns="0" anchor="ctr">
-            <a:noAutofit/>
-          </a:bodyPr>
-          <a:p>
-            <a:pPr defTabSz="914400">
-              <a:lnSpc>
-                <a:spcPct val="100000"/>
-              </a:lnSpc>
-              <a:tabLst>
-                <a:tab pos="0" algn="l"/>
-              </a:tabLst>
-            </a:pPr>
-            <a:r>
-              <a:rPr lang="en-US" sz="1250" b="1" u="none" strike="noStrike">
-                <a:solidFill>
-                  <a:srgbClr val="16262E"/>
-                </a:solidFill>
-                <a:effectLst/>
-                <a:uFillTx/>
-                <a:latin typeface="Calibri"/>
-                <a:ea typeface="Calibri"/>
-              </a:rPr>
-              <a:t>Pendiente: confirmar las dos bios con cada instructor y colocar sus fotografías en los círculos.</a:t>
-            </a:r>
-            <a:endParaRPr lang="en-US" sz="1250" b="0" u="none" strike="noStrike">
-              <a:solidFill>
-                <a:srgbClr val="000000"/>
-              </a:solidFill>
-              <a:effectLst/>
-              <a:uFillTx/>
-              <a:latin typeface="Arial"/>
-            </a:endParaRPr>
-          </a:p>
-        </p:txBody>
-      </p:sp>
     </p:spTree>
   </p:cSld>
   <mc:AlternateContent>
@@ -45824,1652 +45553,6 @@
               <a:t>https://forms.gle/SiAfp4nnpYdbwWPq7</a:t>
             </a:r>
             <a:endParaRPr lang="en-US" sz="4400" b="0" u="none" strike="noStrike">
-              <a:solidFill>
-                <a:srgbClr val="000000"/>
-              </a:solidFill>
-              <a:effectLst/>
-              <a:uFillTx/>
-              <a:latin typeface="Arial"/>
-            </a:endParaRPr>
-          </a:p>
-        </p:txBody>
-      </p:sp>
-    </p:spTree>
-  </p:cSld>
-  <mc:AlternateContent>
-    <mc:Choice Requires="p14">
-      <p:transition spd="slow" p14:dur="2000"/>
-    </mc:Choice>
-    <mc:Fallback>
-      <p:transition spd="slow"/>
-    </mc:Fallback>
-  </mc:AlternateContent>
-</p:sld>
-</file>
-
-<file path=ppt/slides/slide7.xml><?xml version="1.0" encoding="utf-8"?>
-<p:sld xmlns:a="http://schemas.openxmlformats.org/drawingml/2006/main" xmlns:p="http://schemas.openxmlformats.org/presentationml/2006/main" xmlns:r="http://schemas.openxmlformats.org/officeDocument/2006/relationships" xmlns:p14="http://schemas.microsoft.com/office/powerpoint/2010/main" xmlns:p15="http://schemas.microsoft.com/office/powerpoint/2012/main" xmlns:mc="http://schemas.openxmlformats.org/markup-compatibility/2006">
-  <p:cSld>
-    <p:spTree>
-      <p:nvGrpSpPr>
-        <p:cNvPr id="1" name=""/>
-        <p:cNvGrpSpPr/>
-        <p:nvPr/>
-      </p:nvGrpSpPr>
-      <p:grpSpPr>
-        <a:xfrm>
-          <a:off x="0" y="0"/>
-          <a:ext cx="0" cy="0"/>
-          <a:chOff x="0" y="0"/>
-          <a:chExt cx="0" cy="0"/>
-        </a:xfrm>
-      </p:grpSpPr>
-      <p:sp>
-        <p:nvSpPr>
-          <p:cNvPr id="114" name="Text 37"/>
-          <p:cNvSpPr/>
-          <p:nvPr/>
-        </p:nvSpPr>
-        <p:spPr>
-          <a:xfrm>
-            <a:off x="567000" y="402480"/>
-            <a:ext cx="9228600" cy="749520"/>
-          </a:xfrm>
-          <a:prstGeom prst="rect">
-            <a:avLst/>
-          </a:prstGeom>
-          <a:noFill/>
-          <a:ln w="0">
-            <a:noFill/>
-          </a:ln>
-        </p:spPr>
-        <p:style>
-          <a:lnRef idx="0"/>
-          <a:fillRef idx="0"/>
-          <a:effectRef idx="0"/>
-          <a:fontRef idx="minor"/>
-        </p:style>
-        <p:txBody>
-          <a:bodyPr lIns="0" tIns="0" rIns="0" bIns="0" anchor="t">
-            <a:noAutofit/>
-          </a:bodyPr>
-          <a:p>
-            <a:pPr defTabSz="914400">
-              <a:lnSpc>
-                <a:spcPct val="100000"/>
-              </a:lnSpc>
-              <a:tabLst>
-                <a:tab pos="0" algn="l"/>
-              </a:tabLst>
-            </a:pPr>
-            <a:r>
-              <a:rPr lang="en-US" sz="3200" b="1" u="none" strike="noStrike">
-                <a:solidFill>
-                  <a:srgbClr val="16262E"/>
-                </a:solidFill>
-                <a:effectLst/>
-                <a:uFillTx/>
-                <a:latin typeface="Arial"/>
-                <a:ea typeface="Arial"/>
-              </a:rPr>
-              <a:t>Qué te llevas al terminar las dos semanas</a:t>
-            </a:r>
-            <a:endParaRPr lang="en-US" sz="3200" b="0" u="none" strike="noStrike">
-              <a:solidFill>
-                <a:srgbClr val="000000"/>
-              </a:solidFill>
-              <a:effectLst/>
-              <a:uFillTx/>
-              <a:latin typeface="Arial"/>
-            </a:endParaRPr>
-          </a:p>
-        </p:txBody>
-      </p:sp>
-      <p:sp>
-        <p:nvSpPr>
-          <p:cNvPr id="115" name="Shape 23"/>
-          <p:cNvSpPr/>
-          <p:nvPr/>
-        </p:nvSpPr>
-        <p:spPr>
-          <a:xfrm>
-            <a:off x="567000" y="1417680"/>
-            <a:ext cx="3502800" cy="2234880"/>
-          </a:xfrm>
-          <a:prstGeom prst="roundRect">
-            <a:avLst>
-              <a:gd name="adj" fmla="val 3273"/>
-            </a:avLst>
-          </a:prstGeom>
-          <a:solidFill>
-            <a:srgbClr val="F2F5F6"/>
-          </a:solidFill>
-          <a:ln w="12700">
-            <a:solidFill>
-              <a:srgbClr val="F2F5F6"/>
-            </a:solidFill>
-            <a:round/>
-          </a:ln>
-        </p:spPr>
-        <p:style>
-          <a:lnRef idx="0"/>
-          <a:fillRef idx="0"/>
-          <a:effectRef idx="0"/>
-          <a:fontRef idx="minor"/>
-        </p:style>
-        <p:txBody>
-          <a:bodyPr lIns="90000" tIns="45000" rIns="90000" bIns="45000" anchor="t">
-            <a:noAutofit/>
-          </a:bodyPr>
-          <a:p>
-            <a:endParaRPr lang="en-US" sz="1800" b="0" u="none" strike="noStrike">
-              <a:solidFill>
-                <a:srgbClr val="000000"/>
-              </a:solidFill>
-              <a:effectLst/>
-              <a:uFillTx/>
-              <a:latin typeface="Arial"/>
-            </a:endParaRPr>
-          </a:p>
-        </p:txBody>
-      </p:sp>
-      <p:sp>
-        <p:nvSpPr>
-          <p:cNvPr id="116" name="Shape 25"/>
-          <p:cNvSpPr/>
-          <p:nvPr/>
-        </p:nvSpPr>
-        <p:spPr>
-          <a:xfrm>
-            <a:off x="804600" y="1637280"/>
-            <a:ext cx="420120" cy="420120"/>
-          </a:xfrm>
-          <a:prstGeom prst="ellipse">
-            <a:avLst/>
-          </a:prstGeom>
-          <a:solidFill>
-            <a:srgbClr val="2E7D7D"/>
-          </a:solidFill>
-          <a:ln w="12700">
-            <a:solidFill>
-              <a:srgbClr val="2E7D7D"/>
-            </a:solidFill>
-            <a:round/>
-          </a:ln>
-        </p:spPr>
-        <p:style>
-          <a:lnRef idx="0"/>
-          <a:fillRef idx="0"/>
-          <a:effectRef idx="0"/>
-          <a:fontRef idx="minor"/>
-        </p:style>
-        <p:txBody>
-          <a:bodyPr lIns="90000" tIns="45000" rIns="90000" bIns="45000" anchor="t">
-            <a:noAutofit/>
-          </a:bodyPr>
-          <a:p>
-            <a:endParaRPr lang="en-US" sz="1800" b="0" u="none" strike="noStrike">
-              <a:solidFill>
-                <a:srgbClr val="FFFFFF"/>
-              </a:solidFill>
-              <a:effectLst/>
-              <a:uFillTx/>
-              <a:latin typeface="Arial"/>
-            </a:endParaRPr>
-          </a:p>
-        </p:txBody>
-      </p:sp>
-      <p:sp>
-        <p:nvSpPr>
-          <p:cNvPr id="117" name="Text 40"/>
-          <p:cNvSpPr/>
-          <p:nvPr/>
-        </p:nvSpPr>
-        <p:spPr>
-          <a:xfrm>
-            <a:off x="804600" y="1637280"/>
-            <a:ext cx="420120" cy="420120"/>
-          </a:xfrm>
-          <a:prstGeom prst="rect">
-            <a:avLst/>
-          </a:prstGeom>
-          <a:noFill/>
-          <a:ln w="0">
-            <a:noFill/>
-          </a:ln>
-        </p:spPr>
-        <p:style>
-          <a:lnRef idx="0"/>
-          <a:fillRef idx="0"/>
-          <a:effectRef idx="0"/>
-          <a:fontRef idx="minor"/>
-        </p:style>
-        <p:txBody>
-          <a:bodyPr lIns="0" tIns="0" rIns="0" bIns="0" anchor="ctr">
-            <a:noAutofit/>
-          </a:bodyPr>
-          <a:p>
-            <a:pPr algn="ctr" defTabSz="914400">
-              <a:lnSpc>
-                <a:spcPct val="100000"/>
-              </a:lnSpc>
-              <a:tabLst>
-                <a:tab pos="0" algn="l"/>
-              </a:tabLst>
-            </a:pPr>
-            <a:r>
-              <a:rPr lang="en-US" sz="1400" b="1" u="none" strike="noStrike">
-                <a:solidFill>
-                  <a:srgbClr val="FFFFFF"/>
-                </a:solidFill>
-                <a:effectLst/>
-                <a:uFillTx/>
-                <a:latin typeface="Arial"/>
-                <a:ea typeface="Arial"/>
-              </a:rPr>
-              <a:t>1</a:t>
-            </a:r>
-            <a:endParaRPr lang="en-US" sz="1400" b="0" u="none" strike="noStrike">
-              <a:solidFill>
-                <a:srgbClr val="000000"/>
-              </a:solidFill>
-              <a:effectLst/>
-              <a:uFillTx/>
-              <a:latin typeface="Arial"/>
-            </a:endParaRPr>
-          </a:p>
-        </p:txBody>
-      </p:sp>
-      <p:sp>
-        <p:nvSpPr>
-          <p:cNvPr id="118" name="Text 43"/>
-          <p:cNvSpPr/>
-          <p:nvPr/>
-        </p:nvSpPr>
-        <p:spPr>
-          <a:xfrm>
-            <a:off x="804600" y="2204280"/>
-            <a:ext cx="3027240" cy="247320"/>
-          </a:xfrm>
-          <a:prstGeom prst="rect">
-            <a:avLst/>
-          </a:prstGeom>
-          <a:noFill/>
-          <a:ln w="0">
-            <a:noFill/>
-          </a:ln>
-        </p:spPr>
-        <p:style>
-          <a:lnRef idx="0"/>
-          <a:fillRef idx="0"/>
-          <a:effectRef idx="0"/>
-          <a:fontRef idx="minor"/>
-        </p:style>
-        <p:txBody>
-          <a:bodyPr lIns="0" tIns="0" rIns="0" bIns="0" anchor="t">
-            <a:noAutofit/>
-          </a:bodyPr>
-          <a:p>
-            <a:pPr defTabSz="914400">
-              <a:lnSpc>
-                <a:spcPct val="100000"/>
-              </a:lnSpc>
-              <a:tabLst>
-                <a:tab pos="0" algn="l"/>
-              </a:tabLst>
-            </a:pPr>
-            <a:r>
-              <a:rPr lang="en-US" sz="1170" b="1" u="none" strike="noStrike">
-                <a:solidFill>
-                  <a:srgbClr val="16262E"/>
-                </a:solidFill>
-                <a:effectLst/>
-                <a:uFillTx/>
-                <a:latin typeface="Arial"/>
-                <a:ea typeface="Arial"/>
-              </a:rPr>
-              <a:t>Tu bitácora</a:t>
-            </a:r>
-            <a:endParaRPr lang="en-US" sz="1170" b="0" u="none" strike="noStrike">
-              <a:solidFill>
-                <a:srgbClr val="000000"/>
-              </a:solidFill>
-              <a:effectLst/>
-              <a:uFillTx/>
-              <a:latin typeface="Arial"/>
-            </a:endParaRPr>
-          </a:p>
-        </p:txBody>
-      </p:sp>
-      <p:sp>
-        <p:nvSpPr>
-          <p:cNvPr id="119" name="Text 46"/>
-          <p:cNvSpPr/>
-          <p:nvPr/>
-        </p:nvSpPr>
-        <p:spPr>
-          <a:xfrm>
-            <a:off x="804600" y="2598120"/>
-            <a:ext cx="3027240" cy="853200"/>
-          </a:xfrm>
-          <a:prstGeom prst="rect">
-            <a:avLst/>
-          </a:prstGeom>
-          <a:noFill/>
-          <a:ln w="0">
-            <a:noFill/>
-          </a:ln>
-        </p:spPr>
-        <p:style>
-          <a:lnRef idx="0"/>
-          <a:fillRef idx="0"/>
-          <a:effectRef idx="0"/>
-          <a:fontRef idx="minor"/>
-        </p:style>
-        <p:txBody>
-          <a:bodyPr lIns="0" tIns="0" rIns="0" bIns="0" anchor="t">
-            <a:noAutofit/>
-          </a:bodyPr>
-          <a:p>
-            <a:pPr defTabSz="914400">
-              <a:lnSpc>
-                <a:spcPct val="110000"/>
-              </a:lnSpc>
-              <a:tabLst>
-                <a:tab pos="0" algn="l"/>
-              </a:tabLst>
-            </a:pPr>
-            <a:r>
-              <a:rPr lang="en-US" sz="950" b="0" u="none" strike="noStrike">
-                <a:solidFill>
-                  <a:srgbClr val="16262E"/>
-                </a:solidFill>
-                <a:effectLst/>
-                <a:uFillTx/>
-                <a:latin typeface="Calibri"/>
-                <a:ea typeface="Calibri"/>
-              </a:rPr>
-              <a:t>Todo lo que probaste, con la versión de cada prompt y lo que te devolvió. Cuenta dentro del 40 por ciento de laboratorios.</a:t>
-            </a:r>
-            <a:endParaRPr lang="en-US" sz="950" b="0" u="none" strike="noStrike">
-              <a:solidFill>
-                <a:srgbClr val="000000"/>
-              </a:solidFill>
-              <a:effectLst/>
-              <a:uFillTx/>
-              <a:latin typeface="Arial"/>
-            </a:endParaRPr>
-          </a:p>
-        </p:txBody>
-      </p:sp>
-      <p:sp>
-        <p:nvSpPr>
-          <p:cNvPr id="120" name="Shape 29"/>
-          <p:cNvSpPr/>
-          <p:nvPr/>
-        </p:nvSpPr>
-        <p:spPr>
-          <a:xfrm>
-            <a:off x="4344480" y="1417680"/>
-            <a:ext cx="3502800" cy="2234880"/>
-          </a:xfrm>
-          <a:prstGeom prst="roundRect">
-            <a:avLst>
-              <a:gd name="adj" fmla="val 3273"/>
-            </a:avLst>
-          </a:prstGeom>
-          <a:solidFill>
-            <a:srgbClr val="F2F5F6"/>
-          </a:solidFill>
-          <a:ln w="12700">
-            <a:solidFill>
-              <a:srgbClr val="F2F5F6"/>
-            </a:solidFill>
-            <a:round/>
-          </a:ln>
-        </p:spPr>
-        <p:style>
-          <a:lnRef idx="0"/>
-          <a:fillRef idx="0"/>
-          <a:effectRef idx="0"/>
-          <a:fontRef idx="minor"/>
-        </p:style>
-        <p:txBody>
-          <a:bodyPr lIns="90000" tIns="45000" rIns="90000" bIns="45000" anchor="t">
-            <a:noAutofit/>
-          </a:bodyPr>
-          <a:p>
-            <a:endParaRPr lang="en-US" sz="1800" b="0" u="none" strike="noStrike">
-              <a:solidFill>
-                <a:srgbClr val="000000"/>
-              </a:solidFill>
-              <a:effectLst/>
-              <a:uFillTx/>
-              <a:latin typeface="Arial"/>
-            </a:endParaRPr>
-          </a:p>
-        </p:txBody>
-      </p:sp>
-      <p:sp>
-        <p:nvSpPr>
-          <p:cNvPr id="121" name="Shape 36"/>
-          <p:cNvSpPr/>
-          <p:nvPr/>
-        </p:nvSpPr>
-        <p:spPr>
-          <a:xfrm>
-            <a:off x="4582080" y="1637280"/>
-            <a:ext cx="420120" cy="420120"/>
-          </a:xfrm>
-          <a:prstGeom prst="ellipse">
-            <a:avLst/>
-          </a:prstGeom>
-          <a:solidFill>
-            <a:srgbClr val="2E7D7D"/>
-          </a:solidFill>
-          <a:ln w="12700">
-            <a:solidFill>
-              <a:srgbClr val="2E7D7D"/>
-            </a:solidFill>
-            <a:round/>
-          </a:ln>
-        </p:spPr>
-        <p:style>
-          <a:lnRef idx="0"/>
-          <a:fillRef idx="0"/>
-          <a:effectRef idx="0"/>
-          <a:fontRef idx="minor"/>
-        </p:style>
-        <p:txBody>
-          <a:bodyPr lIns="90000" tIns="45000" rIns="90000" bIns="45000" anchor="t">
-            <a:noAutofit/>
-          </a:bodyPr>
-          <a:p>
-            <a:endParaRPr lang="en-US" sz="1800" b="0" u="none" strike="noStrike">
-              <a:solidFill>
-                <a:srgbClr val="FFFFFF"/>
-              </a:solidFill>
-              <a:effectLst/>
-              <a:uFillTx/>
-              <a:latin typeface="Arial"/>
-            </a:endParaRPr>
-          </a:p>
-        </p:txBody>
-      </p:sp>
-      <p:sp>
-        <p:nvSpPr>
-          <p:cNvPr id="122" name="Text 49"/>
-          <p:cNvSpPr/>
-          <p:nvPr/>
-        </p:nvSpPr>
-        <p:spPr>
-          <a:xfrm>
-            <a:off x="4582080" y="1637280"/>
-            <a:ext cx="420120" cy="420120"/>
-          </a:xfrm>
-          <a:prstGeom prst="rect">
-            <a:avLst/>
-          </a:prstGeom>
-          <a:noFill/>
-          <a:ln w="0">
-            <a:noFill/>
-          </a:ln>
-        </p:spPr>
-        <p:style>
-          <a:lnRef idx="0"/>
-          <a:fillRef idx="0"/>
-          <a:effectRef idx="0"/>
-          <a:fontRef idx="minor"/>
-        </p:style>
-        <p:txBody>
-          <a:bodyPr lIns="0" tIns="0" rIns="0" bIns="0" anchor="ctr">
-            <a:noAutofit/>
-          </a:bodyPr>
-          <a:p>
-            <a:pPr algn="ctr" defTabSz="914400">
-              <a:lnSpc>
-                <a:spcPct val="100000"/>
-              </a:lnSpc>
-              <a:tabLst>
-                <a:tab pos="0" algn="l"/>
-              </a:tabLst>
-            </a:pPr>
-            <a:r>
-              <a:rPr lang="en-US" sz="1400" b="1" u="none" strike="noStrike">
-                <a:solidFill>
-                  <a:srgbClr val="FFFFFF"/>
-                </a:solidFill>
-                <a:effectLst/>
-                <a:uFillTx/>
-                <a:latin typeface="Arial"/>
-                <a:ea typeface="Arial"/>
-              </a:rPr>
-              <a:t>2</a:t>
-            </a:r>
-            <a:endParaRPr lang="en-US" sz="1400" b="0" u="none" strike="noStrike">
-              <a:solidFill>
-                <a:srgbClr val="000000"/>
-              </a:solidFill>
-              <a:effectLst/>
-              <a:uFillTx/>
-              <a:latin typeface="Arial"/>
-            </a:endParaRPr>
-          </a:p>
-        </p:txBody>
-      </p:sp>
-      <p:sp>
-        <p:nvSpPr>
-          <p:cNvPr id="123" name="Text 50"/>
-          <p:cNvSpPr/>
-          <p:nvPr/>
-        </p:nvSpPr>
-        <p:spPr>
-          <a:xfrm>
-            <a:off x="4582080" y="2204280"/>
-            <a:ext cx="3027240" cy="247320"/>
-          </a:xfrm>
-          <a:prstGeom prst="rect">
-            <a:avLst/>
-          </a:prstGeom>
-          <a:noFill/>
-          <a:ln w="0">
-            <a:noFill/>
-          </a:ln>
-        </p:spPr>
-        <p:style>
-          <a:lnRef idx="0"/>
-          <a:fillRef idx="0"/>
-          <a:effectRef idx="0"/>
-          <a:fontRef idx="minor"/>
-        </p:style>
-        <p:txBody>
-          <a:bodyPr lIns="0" tIns="0" rIns="0" bIns="0" anchor="t">
-            <a:noAutofit/>
-          </a:bodyPr>
-          <a:p>
-            <a:pPr defTabSz="914400">
-              <a:lnSpc>
-                <a:spcPct val="100000"/>
-              </a:lnSpc>
-              <a:tabLst>
-                <a:tab pos="0" algn="l"/>
-              </a:tabLst>
-            </a:pPr>
-            <a:r>
-              <a:rPr lang="en-US" sz="1170" b="1" u="none" strike="noStrike">
-                <a:solidFill>
-                  <a:srgbClr val="16262E"/>
-                </a:solidFill>
-                <a:effectLst/>
-                <a:uFillTx/>
-                <a:latin typeface="Arial"/>
-                <a:ea typeface="Arial"/>
-              </a:rPr>
-              <a:t>Tu biblioteca de prompts</a:t>
-            </a:r>
-            <a:endParaRPr lang="en-US" sz="1170" b="0" u="none" strike="noStrike">
-              <a:solidFill>
-                <a:srgbClr val="000000"/>
-              </a:solidFill>
-              <a:effectLst/>
-              <a:uFillTx/>
-              <a:latin typeface="Arial"/>
-            </a:endParaRPr>
-          </a:p>
-        </p:txBody>
-      </p:sp>
-      <p:sp>
-        <p:nvSpPr>
-          <p:cNvPr id="124" name="Text 51"/>
-          <p:cNvSpPr/>
-          <p:nvPr/>
-        </p:nvSpPr>
-        <p:spPr>
-          <a:xfrm>
-            <a:off x="4582080" y="2598120"/>
-            <a:ext cx="3027240" cy="853200"/>
-          </a:xfrm>
-          <a:prstGeom prst="rect">
-            <a:avLst/>
-          </a:prstGeom>
-          <a:noFill/>
-          <a:ln w="0">
-            <a:noFill/>
-          </a:ln>
-        </p:spPr>
-        <p:style>
-          <a:lnRef idx="0"/>
-          <a:fillRef idx="0"/>
-          <a:effectRef idx="0"/>
-          <a:fontRef idx="minor"/>
-        </p:style>
-        <p:txBody>
-          <a:bodyPr lIns="0" tIns="0" rIns="0" bIns="0" anchor="t">
-            <a:noAutofit/>
-          </a:bodyPr>
-          <a:p>
-            <a:pPr defTabSz="914400">
-              <a:lnSpc>
-                <a:spcPct val="110000"/>
-              </a:lnSpc>
-              <a:tabLst>
-                <a:tab pos="0" algn="l"/>
-              </a:tabLst>
-            </a:pPr>
-            <a:r>
-              <a:rPr lang="en-US" sz="950" b="0" u="none" strike="noStrike">
-                <a:solidFill>
-                  <a:srgbClr val="16262E"/>
-                </a:solidFill>
-                <a:effectLst/>
-                <a:uFillTx/>
-                <a:latin typeface="Calibri"/>
-                <a:ea typeface="Calibri"/>
-              </a:rPr>
-              <a:t>Al menos ocho prompts que ya funcionan para tareas reales de tu trabajo.</a:t>
-            </a:r>
-            <a:endParaRPr lang="en-US" sz="950" b="0" u="none" strike="noStrike">
-              <a:solidFill>
-                <a:srgbClr val="000000"/>
-              </a:solidFill>
-              <a:effectLst/>
-              <a:uFillTx/>
-              <a:latin typeface="Arial"/>
-            </a:endParaRPr>
-          </a:p>
-        </p:txBody>
-      </p:sp>
-      <p:sp>
-        <p:nvSpPr>
-          <p:cNvPr id="125" name="Shape 38"/>
-          <p:cNvSpPr/>
-          <p:nvPr/>
-        </p:nvSpPr>
-        <p:spPr>
-          <a:xfrm>
-            <a:off x="8121600" y="1417680"/>
-            <a:ext cx="3502800" cy="2234880"/>
-          </a:xfrm>
-          <a:prstGeom prst="roundRect">
-            <a:avLst>
-              <a:gd name="adj" fmla="val 3273"/>
-            </a:avLst>
-          </a:prstGeom>
-          <a:solidFill>
-            <a:srgbClr val="F2F5F6"/>
-          </a:solidFill>
-          <a:ln w="12700">
-            <a:solidFill>
-              <a:srgbClr val="F2F5F6"/>
-            </a:solidFill>
-            <a:round/>
-          </a:ln>
-        </p:spPr>
-        <p:style>
-          <a:lnRef idx="0"/>
-          <a:fillRef idx="0"/>
-          <a:effectRef idx="0"/>
-          <a:fontRef idx="minor"/>
-        </p:style>
-        <p:txBody>
-          <a:bodyPr lIns="90000" tIns="45000" rIns="90000" bIns="45000" anchor="t">
-            <a:noAutofit/>
-          </a:bodyPr>
-          <a:p>
-            <a:endParaRPr lang="en-US" sz="1800" b="0" u="none" strike="noStrike">
-              <a:solidFill>
-                <a:srgbClr val="000000"/>
-              </a:solidFill>
-              <a:effectLst/>
-              <a:uFillTx/>
-              <a:latin typeface="Arial"/>
-            </a:endParaRPr>
-          </a:p>
-        </p:txBody>
-      </p:sp>
-      <p:sp>
-        <p:nvSpPr>
-          <p:cNvPr id="126" name="Shape 39"/>
-          <p:cNvSpPr/>
-          <p:nvPr/>
-        </p:nvSpPr>
-        <p:spPr>
-          <a:xfrm>
-            <a:off x="8359560" y="1637280"/>
-            <a:ext cx="420120" cy="420120"/>
-          </a:xfrm>
-          <a:prstGeom prst="ellipse">
-            <a:avLst/>
-          </a:prstGeom>
-          <a:solidFill>
-            <a:srgbClr val="2E7D7D"/>
-          </a:solidFill>
-          <a:ln w="12700">
-            <a:solidFill>
-              <a:srgbClr val="2E7D7D"/>
-            </a:solidFill>
-            <a:round/>
-          </a:ln>
-        </p:spPr>
-        <p:style>
-          <a:lnRef idx="0"/>
-          <a:fillRef idx="0"/>
-          <a:effectRef idx="0"/>
-          <a:fontRef idx="minor"/>
-        </p:style>
-        <p:txBody>
-          <a:bodyPr lIns="90000" tIns="45000" rIns="90000" bIns="45000" anchor="t">
-            <a:noAutofit/>
-          </a:bodyPr>
-          <a:p>
-            <a:endParaRPr lang="en-US" sz="1800" b="0" u="none" strike="noStrike">
-              <a:solidFill>
-                <a:srgbClr val="FFFFFF"/>
-              </a:solidFill>
-              <a:effectLst/>
-              <a:uFillTx/>
-              <a:latin typeface="Arial"/>
-            </a:endParaRPr>
-          </a:p>
-        </p:txBody>
-      </p:sp>
-      <p:sp>
-        <p:nvSpPr>
-          <p:cNvPr id="127" name="Text 52"/>
-          <p:cNvSpPr/>
-          <p:nvPr/>
-        </p:nvSpPr>
-        <p:spPr>
-          <a:xfrm>
-            <a:off x="8359560" y="1637280"/>
-            <a:ext cx="420120" cy="420120"/>
-          </a:xfrm>
-          <a:prstGeom prst="rect">
-            <a:avLst/>
-          </a:prstGeom>
-          <a:noFill/>
-          <a:ln w="0">
-            <a:noFill/>
-          </a:ln>
-        </p:spPr>
-        <p:style>
-          <a:lnRef idx="0"/>
-          <a:fillRef idx="0"/>
-          <a:effectRef idx="0"/>
-          <a:fontRef idx="minor"/>
-        </p:style>
-        <p:txBody>
-          <a:bodyPr lIns="0" tIns="0" rIns="0" bIns="0" anchor="ctr">
-            <a:noAutofit/>
-          </a:bodyPr>
-          <a:p>
-            <a:pPr algn="ctr" defTabSz="914400">
-              <a:lnSpc>
-                <a:spcPct val="100000"/>
-              </a:lnSpc>
-              <a:tabLst>
-                <a:tab pos="0" algn="l"/>
-              </a:tabLst>
-            </a:pPr>
-            <a:r>
-              <a:rPr lang="en-US" sz="1400" b="1" u="none" strike="noStrike">
-                <a:solidFill>
-                  <a:srgbClr val="FFFFFF"/>
-                </a:solidFill>
-                <a:effectLst/>
-                <a:uFillTx/>
-                <a:latin typeface="Arial"/>
-                <a:ea typeface="Arial"/>
-              </a:rPr>
-              <a:t>3</a:t>
-            </a:r>
-            <a:endParaRPr lang="en-US" sz="1400" b="0" u="none" strike="noStrike">
-              <a:solidFill>
-                <a:srgbClr val="000000"/>
-              </a:solidFill>
-              <a:effectLst/>
-              <a:uFillTx/>
-              <a:latin typeface="Arial"/>
-            </a:endParaRPr>
-          </a:p>
-        </p:txBody>
-      </p:sp>
-      <p:sp>
-        <p:nvSpPr>
-          <p:cNvPr id="128" name="Text 53"/>
-          <p:cNvSpPr/>
-          <p:nvPr/>
-        </p:nvSpPr>
-        <p:spPr>
-          <a:xfrm>
-            <a:off x="8359560" y="2204280"/>
-            <a:ext cx="3027240" cy="247320"/>
-          </a:xfrm>
-          <a:prstGeom prst="rect">
-            <a:avLst/>
-          </a:prstGeom>
-          <a:noFill/>
-          <a:ln w="0">
-            <a:noFill/>
-          </a:ln>
-        </p:spPr>
-        <p:style>
-          <a:lnRef idx="0"/>
-          <a:fillRef idx="0"/>
-          <a:effectRef idx="0"/>
-          <a:fontRef idx="minor"/>
-        </p:style>
-        <p:txBody>
-          <a:bodyPr lIns="0" tIns="0" rIns="0" bIns="0" anchor="t">
-            <a:noAutofit/>
-          </a:bodyPr>
-          <a:p>
-            <a:pPr defTabSz="914400">
-              <a:lnSpc>
-                <a:spcPct val="100000"/>
-              </a:lnSpc>
-              <a:tabLst>
-                <a:tab pos="0" algn="l"/>
-              </a:tabLst>
-            </a:pPr>
-            <a:r>
-              <a:rPr lang="en-US" sz="1170" b="1" u="none" strike="noStrike">
-                <a:solidFill>
-                  <a:srgbClr val="16262E"/>
-                </a:solidFill>
-                <a:effectLst/>
-                <a:uFillTx/>
-                <a:latin typeface="Arial"/>
-                <a:ea typeface="Arial"/>
-              </a:rPr>
-              <a:t>Un dictamen de validación</a:t>
-            </a:r>
-            <a:endParaRPr lang="en-US" sz="1170" b="0" u="none" strike="noStrike">
-              <a:solidFill>
-                <a:srgbClr val="000000"/>
-              </a:solidFill>
-              <a:effectLst/>
-              <a:uFillTx/>
-              <a:latin typeface="Arial"/>
-            </a:endParaRPr>
-          </a:p>
-        </p:txBody>
-      </p:sp>
-      <p:sp>
-        <p:nvSpPr>
-          <p:cNvPr id="129" name="Text 54"/>
-          <p:cNvSpPr/>
-          <p:nvPr/>
-        </p:nvSpPr>
-        <p:spPr>
-          <a:xfrm>
-            <a:off x="8359560" y="2598120"/>
-            <a:ext cx="3027240" cy="853200"/>
-          </a:xfrm>
-          <a:prstGeom prst="rect">
-            <a:avLst/>
-          </a:prstGeom>
-          <a:noFill/>
-          <a:ln w="0">
-            <a:noFill/>
-          </a:ln>
-        </p:spPr>
-        <p:style>
-          <a:lnRef idx="0"/>
-          <a:fillRef idx="0"/>
-          <a:effectRef idx="0"/>
-          <a:fontRef idx="minor"/>
-        </p:style>
-        <p:txBody>
-          <a:bodyPr lIns="0" tIns="0" rIns="0" bIns="0" anchor="t">
-            <a:noAutofit/>
-          </a:bodyPr>
-          <a:p>
-            <a:pPr defTabSz="914400">
-              <a:lnSpc>
-                <a:spcPct val="110000"/>
-              </a:lnSpc>
-              <a:tabLst>
-                <a:tab pos="0" algn="l"/>
-              </a:tabLst>
-            </a:pPr>
-            <a:r>
-              <a:rPr lang="en-US" sz="950" b="0" u="none" strike="noStrike">
-                <a:solidFill>
-                  <a:srgbClr val="16262E"/>
-                </a:solidFill>
-                <a:effectLst/>
-                <a:uFillTx/>
-                <a:latin typeface="Calibri"/>
-                <a:ea typeface="Calibri"/>
-              </a:rPr>
-              <a:t>De un informe de evaluación, hecho con el protocolo del curso.</a:t>
-            </a:r>
-            <a:endParaRPr lang="en-US" sz="950" b="0" u="none" strike="noStrike">
-              <a:solidFill>
-                <a:srgbClr val="000000"/>
-              </a:solidFill>
-              <a:effectLst/>
-              <a:uFillTx/>
-              <a:latin typeface="Arial"/>
-            </a:endParaRPr>
-          </a:p>
-        </p:txBody>
-      </p:sp>
-      <p:sp>
-        <p:nvSpPr>
-          <p:cNvPr id="130" name="Shape 41"/>
-          <p:cNvSpPr/>
-          <p:nvPr/>
-        </p:nvSpPr>
-        <p:spPr>
-          <a:xfrm>
-            <a:off x="567000" y="3927240"/>
-            <a:ext cx="3502800" cy="2234880"/>
-          </a:xfrm>
-          <a:prstGeom prst="roundRect">
-            <a:avLst>
-              <a:gd name="adj" fmla="val 3273"/>
-            </a:avLst>
-          </a:prstGeom>
-          <a:solidFill>
-            <a:srgbClr val="F2F5F6"/>
-          </a:solidFill>
-          <a:ln w="12700">
-            <a:solidFill>
-              <a:srgbClr val="F2F5F6"/>
-            </a:solidFill>
-            <a:round/>
-          </a:ln>
-        </p:spPr>
-        <p:style>
-          <a:lnRef idx="0"/>
-          <a:fillRef idx="0"/>
-          <a:effectRef idx="0"/>
-          <a:fontRef idx="minor"/>
-        </p:style>
-        <p:txBody>
-          <a:bodyPr lIns="90000" tIns="45000" rIns="90000" bIns="45000" anchor="t">
-            <a:noAutofit/>
-          </a:bodyPr>
-          <a:p>
-            <a:endParaRPr lang="en-US" sz="1800" b="0" u="none" strike="noStrike">
-              <a:solidFill>
-                <a:srgbClr val="000000"/>
-              </a:solidFill>
-              <a:effectLst/>
-              <a:uFillTx/>
-              <a:latin typeface="Arial"/>
-            </a:endParaRPr>
-          </a:p>
-        </p:txBody>
-      </p:sp>
-      <p:sp>
-        <p:nvSpPr>
-          <p:cNvPr id="131" name="Shape 42"/>
-          <p:cNvSpPr/>
-          <p:nvPr/>
-        </p:nvSpPr>
-        <p:spPr>
-          <a:xfrm>
-            <a:off x="804600" y="4146840"/>
-            <a:ext cx="420120" cy="420120"/>
-          </a:xfrm>
-          <a:prstGeom prst="ellipse">
-            <a:avLst/>
-          </a:prstGeom>
-          <a:solidFill>
-            <a:srgbClr val="2E7D7D"/>
-          </a:solidFill>
-          <a:ln w="12700">
-            <a:solidFill>
-              <a:srgbClr val="2E7D7D"/>
-            </a:solidFill>
-            <a:round/>
-          </a:ln>
-        </p:spPr>
-        <p:style>
-          <a:lnRef idx="0"/>
-          <a:fillRef idx="0"/>
-          <a:effectRef idx="0"/>
-          <a:fontRef idx="minor"/>
-        </p:style>
-        <p:txBody>
-          <a:bodyPr lIns="90000" tIns="45000" rIns="90000" bIns="45000" anchor="t">
-            <a:noAutofit/>
-          </a:bodyPr>
-          <a:p>
-            <a:endParaRPr lang="en-US" sz="1800" b="0" u="none" strike="noStrike">
-              <a:solidFill>
-                <a:srgbClr val="FFFFFF"/>
-              </a:solidFill>
-              <a:effectLst/>
-              <a:uFillTx/>
-              <a:latin typeface="Arial"/>
-            </a:endParaRPr>
-          </a:p>
-        </p:txBody>
-      </p:sp>
-      <p:sp>
-        <p:nvSpPr>
-          <p:cNvPr id="132" name="Text 55"/>
-          <p:cNvSpPr/>
-          <p:nvPr/>
-        </p:nvSpPr>
-        <p:spPr>
-          <a:xfrm>
-            <a:off x="804600" y="4146840"/>
-            <a:ext cx="420120" cy="420120"/>
-          </a:xfrm>
-          <a:prstGeom prst="rect">
-            <a:avLst/>
-          </a:prstGeom>
-          <a:noFill/>
-          <a:ln w="0">
-            <a:noFill/>
-          </a:ln>
-        </p:spPr>
-        <p:style>
-          <a:lnRef idx="0"/>
-          <a:fillRef idx="0"/>
-          <a:effectRef idx="0"/>
-          <a:fontRef idx="minor"/>
-        </p:style>
-        <p:txBody>
-          <a:bodyPr lIns="0" tIns="0" rIns="0" bIns="0" anchor="ctr">
-            <a:noAutofit/>
-          </a:bodyPr>
-          <a:p>
-            <a:pPr algn="ctr" defTabSz="914400">
-              <a:lnSpc>
-                <a:spcPct val="100000"/>
-              </a:lnSpc>
-              <a:tabLst>
-                <a:tab pos="0" algn="l"/>
-              </a:tabLst>
-            </a:pPr>
-            <a:r>
-              <a:rPr lang="en-US" sz="1400" b="1" u="none" strike="noStrike">
-                <a:solidFill>
-                  <a:srgbClr val="FFFFFF"/>
-                </a:solidFill>
-                <a:effectLst/>
-                <a:uFillTx/>
-                <a:latin typeface="Arial"/>
-                <a:ea typeface="Arial"/>
-              </a:rPr>
-              <a:t>4</a:t>
-            </a:r>
-            <a:endParaRPr lang="en-US" sz="1400" b="0" u="none" strike="noStrike">
-              <a:solidFill>
-                <a:srgbClr val="000000"/>
-              </a:solidFill>
-              <a:effectLst/>
-              <a:uFillTx/>
-              <a:latin typeface="Arial"/>
-            </a:endParaRPr>
-          </a:p>
-        </p:txBody>
-      </p:sp>
-      <p:sp>
-        <p:nvSpPr>
-          <p:cNvPr id="133" name="Text 56"/>
-          <p:cNvSpPr/>
-          <p:nvPr/>
-        </p:nvSpPr>
-        <p:spPr>
-          <a:xfrm>
-            <a:off x="804600" y="4713840"/>
-            <a:ext cx="3027240" cy="247320"/>
-          </a:xfrm>
-          <a:prstGeom prst="rect">
-            <a:avLst/>
-          </a:prstGeom>
-          <a:noFill/>
-          <a:ln w="0">
-            <a:noFill/>
-          </a:ln>
-        </p:spPr>
-        <p:style>
-          <a:lnRef idx="0"/>
-          <a:fillRef idx="0"/>
-          <a:effectRef idx="0"/>
-          <a:fontRef idx="minor"/>
-        </p:style>
-        <p:txBody>
-          <a:bodyPr lIns="0" tIns="0" rIns="0" bIns="0" anchor="t">
-            <a:noAutofit/>
-          </a:bodyPr>
-          <a:p>
-            <a:pPr defTabSz="914400">
-              <a:lnSpc>
-                <a:spcPct val="100000"/>
-              </a:lnSpc>
-              <a:tabLst>
-                <a:tab pos="0" algn="l"/>
-              </a:tabLst>
-            </a:pPr>
-            <a:r>
-              <a:rPr lang="en-US" sz="1170" b="1" u="none" strike="noStrike">
-                <a:solidFill>
-                  <a:srgbClr val="16262E"/>
-                </a:solidFill>
-                <a:effectLst/>
-                <a:uFillTx/>
-                <a:latin typeface="Arial"/>
-                <a:ea typeface="Arial"/>
-              </a:rPr>
-              <a:t>Una matriz de evidencia</a:t>
-            </a:r>
-            <a:endParaRPr lang="en-US" sz="1170" b="0" u="none" strike="noStrike">
-              <a:solidFill>
-                <a:srgbClr val="000000"/>
-              </a:solidFill>
-              <a:effectLst/>
-              <a:uFillTx/>
-              <a:latin typeface="Arial"/>
-            </a:endParaRPr>
-          </a:p>
-        </p:txBody>
-      </p:sp>
-      <p:sp>
-        <p:nvSpPr>
-          <p:cNvPr id="134" name="Text 57"/>
-          <p:cNvSpPr/>
-          <p:nvPr/>
-        </p:nvSpPr>
-        <p:spPr>
-          <a:xfrm>
-            <a:off x="804600" y="5107680"/>
-            <a:ext cx="3027240" cy="853200"/>
-          </a:xfrm>
-          <a:prstGeom prst="rect">
-            <a:avLst/>
-          </a:prstGeom>
-          <a:noFill/>
-          <a:ln w="0">
-            <a:noFill/>
-          </a:ln>
-        </p:spPr>
-        <p:style>
-          <a:lnRef idx="0"/>
-          <a:fillRef idx="0"/>
-          <a:effectRef idx="0"/>
-          <a:fontRef idx="minor"/>
-        </p:style>
-        <p:txBody>
-          <a:bodyPr lIns="0" tIns="0" rIns="0" bIns="0" anchor="t">
-            <a:noAutofit/>
-          </a:bodyPr>
-          <a:p>
-            <a:pPr defTabSz="914400">
-              <a:lnSpc>
-                <a:spcPct val="110000"/>
-              </a:lnSpc>
-              <a:tabLst>
-                <a:tab pos="0" algn="l"/>
-              </a:tabLst>
-            </a:pPr>
-            <a:r>
-              <a:rPr lang="en-US" sz="950" b="0" u="none" strike="noStrike">
-                <a:solidFill>
-                  <a:srgbClr val="16262E"/>
-                </a:solidFill>
-                <a:effectLst/>
-                <a:uFillTx/>
-                <a:latin typeface="Calibri"/>
-                <a:ea typeface="Calibri"/>
-              </a:rPr>
-              <a:t>Con cada afirmación ligada al documento y la sección de donde salió.</a:t>
-            </a:r>
-            <a:endParaRPr lang="en-US" sz="950" b="0" u="none" strike="noStrike">
-              <a:solidFill>
-                <a:srgbClr val="000000"/>
-              </a:solidFill>
-              <a:effectLst/>
-              <a:uFillTx/>
-              <a:latin typeface="Arial"/>
-            </a:endParaRPr>
-          </a:p>
-        </p:txBody>
-      </p:sp>
-      <p:sp>
-        <p:nvSpPr>
-          <p:cNvPr id="135" name="Shape 44"/>
-          <p:cNvSpPr/>
-          <p:nvPr/>
-        </p:nvSpPr>
-        <p:spPr>
-          <a:xfrm>
-            <a:off x="4344480" y="3927240"/>
-            <a:ext cx="3502800" cy="2234880"/>
-          </a:xfrm>
-          <a:prstGeom prst="roundRect">
-            <a:avLst>
-              <a:gd name="adj" fmla="val 3273"/>
-            </a:avLst>
-          </a:prstGeom>
-          <a:solidFill>
-            <a:srgbClr val="F2F5F6"/>
-          </a:solidFill>
-          <a:ln w="12700">
-            <a:solidFill>
-              <a:srgbClr val="F2F5F6"/>
-            </a:solidFill>
-            <a:round/>
-          </a:ln>
-        </p:spPr>
-        <p:style>
-          <a:lnRef idx="0"/>
-          <a:fillRef idx="0"/>
-          <a:effectRef idx="0"/>
-          <a:fontRef idx="minor"/>
-        </p:style>
-        <p:txBody>
-          <a:bodyPr lIns="90000" tIns="45000" rIns="90000" bIns="45000" anchor="t">
-            <a:noAutofit/>
-          </a:bodyPr>
-          <a:p>
-            <a:endParaRPr lang="en-US" sz="1800" b="0" u="none" strike="noStrike">
-              <a:solidFill>
-                <a:srgbClr val="000000"/>
-              </a:solidFill>
-              <a:effectLst/>
-              <a:uFillTx/>
-              <a:latin typeface="Arial"/>
-            </a:endParaRPr>
-          </a:p>
-        </p:txBody>
-      </p:sp>
-      <p:sp>
-        <p:nvSpPr>
-          <p:cNvPr id="136" name="Shape 45"/>
-          <p:cNvSpPr/>
-          <p:nvPr/>
-        </p:nvSpPr>
-        <p:spPr>
-          <a:xfrm>
-            <a:off x="4582080" y="4146840"/>
-            <a:ext cx="420120" cy="420120"/>
-          </a:xfrm>
-          <a:prstGeom prst="ellipse">
-            <a:avLst/>
-          </a:prstGeom>
-          <a:solidFill>
-            <a:srgbClr val="2E7D7D"/>
-          </a:solidFill>
-          <a:ln w="12700">
-            <a:solidFill>
-              <a:srgbClr val="2E7D7D"/>
-            </a:solidFill>
-            <a:round/>
-          </a:ln>
-        </p:spPr>
-        <p:style>
-          <a:lnRef idx="0"/>
-          <a:fillRef idx="0"/>
-          <a:effectRef idx="0"/>
-          <a:fontRef idx="minor"/>
-        </p:style>
-        <p:txBody>
-          <a:bodyPr lIns="90000" tIns="45000" rIns="90000" bIns="45000" anchor="t">
-            <a:noAutofit/>
-          </a:bodyPr>
-          <a:p>
-            <a:endParaRPr lang="en-US" sz="1800" b="0" u="none" strike="noStrike">
-              <a:solidFill>
-                <a:srgbClr val="FFFFFF"/>
-              </a:solidFill>
-              <a:effectLst/>
-              <a:uFillTx/>
-              <a:latin typeface="Arial"/>
-            </a:endParaRPr>
-          </a:p>
-        </p:txBody>
-      </p:sp>
-      <p:sp>
-        <p:nvSpPr>
-          <p:cNvPr id="137" name="Text 58"/>
-          <p:cNvSpPr/>
-          <p:nvPr/>
-        </p:nvSpPr>
-        <p:spPr>
-          <a:xfrm>
-            <a:off x="4582080" y="4146840"/>
-            <a:ext cx="420120" cy="420120"/>
-          </a:xfrm>
-          <a:prstGeom prst="rect">
-            <a:avLst/>
-          </a:prstGeom>
-          <a:noFill/>
-          <a:ln w="0">
-            <a:noFill/>
-          </a:ln>
-        </p:spPr>
-        <p:style>
-          <a:lnRef idx="0"/>
-          <a:fillRef idx="0"/>
-          <a:effectRef idx="0"/>
-          <a:fontRef idx="minor"/>
-        </p:style>
-        <p:txBody>
-          <a:bodyPr lIns="0" tIns="0" rIns="0" bIns="0" anchor="ctr">
-            <a:noAutofit/>
-          </a:bodyPr>
-          <a:p>
-            <a:pPr algn="ctr" defTabSz="914400">
-              <a:lnSpc>
-                <a:spcPct val="100000"/>
-              </a:lnSpc>
-              <a:tabLst>
-                <a:tab pos="0" algn="l"/>
-              </a:tabLst>
-            </a:pPr>
-            <a:r>
-              <a:rPr lang="en-US" sz="1400" b="1" u="none" strike="noStrike">
-                <a:solidFill>
-                  <a:srgbClr val="FFFFFF"/>
-                </a:solidFill>
-                <a:effectLst/>
-                <a:uFillTx/>
-                <a:latin typeface="Arial"/>
-                <a:ea typeface="Arial"/>
-              </a:rPr>
-              <a:t>5</a:t>
-            </a:r>
-            <a:endParaRPr lang="en-US" sz="1400" b="0" u="none" strike="noStrike">
-              <a:solidFill>
-                <a:srgbClr val="000000"/>
-              </a:solidFill>
-              <a:effectLst/>
-              <a:uFillTx/>
-              <a:latin typeface="Arial"/>
-            </a:endParaRPr>
-          </a:p>
-        </p:txBody>
-      </p:sp>
-      <p:sp>
-        <p:nvSpPr>
-          <p:cNvPr id="138" name="Text 59"/>
-          <p:cNvSpPr/>
-          <p:nvPr/>
-        </p:nvSpPr>
-        <p:spPr>
-          <a:xfrm>
-            <a:off x="4582080" y="4713840"/>
-            <a:ext cx="3027240" cy="247320"/>
-          </a:xfrm>
-          <a:prstGeom prst="rect">
-            <a:avLst/>
-          </a:prstGeom>
-          <a:noFill/>
-          <a:ln w="0">
-            <a:noFill/>
-          </a:ln>
-        </p:spPr>
-        <p:style>
-          <a:lnRef idx="0"/>
-          <a:fillRef idx="0"/>
-          <a:effectRef idx="0"/>
-          <a:fontRef idx="minor"/>
-        </p:style>
-        <p:txBody>
-          <a:bodyPr lIns="0" tIns="0" rIns="0" bIns="0" anchor="t">
-            <a:noAutofit/>
-          </a:bodyPr>
-          <a:p>
-            <a:pPr defTabSz="914400">
-              <a:lnSpc>
-                <a:spcPct val="100000"/>
-              </a:lnSpc>
-              <a:tabLst>
-                <a:tab pos="0" algn="l"/>
-              </a:tabLst>
-            </a:pPr>
-            <a:r>
-              <a:rPr lang="en-US" sz="1170" b="1" u="none" strike="noStrike">
-                <a:solidFill>
-                  <a:srgbClr val="16262E"/>
-                </a:solidFill>
-                <a:effectLst/>
-                <a:uFillTx/>
-                <a:latin typeface="Arial"/>
-                <a:ea typeface="Arial"/>
-              </a:rPr>
-              <a:t>Un cuadro comparativo</a:t>
-            </a:r>
-            <a:endParaRPr lang="en-US" sz="1170" b="0" u="none" strike="noStrike">
-              <a:solidFill>
-                <a:srgbClr val="000000"/>
-              </a:solidFill>
-              <a:effectLst/>
-              <a:uFillTx/>
-              <a:latin typeface="Arial"/>
-            </a:endParaRPr>
-          </a:p>
-        </p:txBody>
-      </p:sp>
-      <p:sp>
-        <p:nvSpPr>
-          <p:cNvPr id="139" name="Text 60"/>
-          <p:cNvSpPr/>
-          <p:nvPr/>
-        </p:nvSpPr>
-        <p:spPr>
-          <a:xfrm>
-            <a:off x="4582080" y="5107680"/>
-            <a:ext cx="3027240" cy="853200"/>
-          </a:xfrm>
-          <a:prstGeom prst="rect">
-            <a:avLst/>
-          </a:prstGeom>
-          <a:noFill/>
-          <a:ln w="0">
-            <a:noFill/>
-          </a:ln>
-        </p:spPr>
-        <p:style>
-          <a:lnRef idx="0"/>
-          <a:fillRef idx="0"/>
-          <a:effectRef idx="0"/>
-          <a:fontRef idx="minor"/>
-        </p:style>
-        <p:txBody>
-          <a:bodyPr lIns="0" tIns="0" rIns="0" bIns="0" anchor="t">
-            <a:noAutofit/>
-          </a:bodyPr>
-          <a:p>
-            <a:pPr defTabSz="914400">
-              <a:lnSpc>
-                <a:spcPct val="110000"/>
-              </a:lnSpc>
-              <a:tabLst>
-                <a:tab pos="0" algn="l"/>
-              </a:tabLst>
-            </a:pPr>
-            <a:r>
-              <a:rPr lang="en-US" sz="950" b="0" u="none" strike="noStrike">
-                <a:solidFill>
-                  <a:srgbClr val="16262E"/>
-                </a:solidFill>
-                <a:effectLst/>
-                <a:uFillTx/>
-                <a:latin typeface="Calibri"/>
-                <a:ea typeface="Calibri"/>
-              </a:rPr>
-              <a:t>De las plataformas de análisis cualitativo, con tu propia evaluación de cuál sirve para qué.</a:t>
-            </a:r>
-            <a:endParaRPr lang="en-US" sz="950" b="0" u="none" strike="noStrike">
-              <a:solidFill>
-                <a:srgbClr val="000000"/>
-              </a:solidFill>
-              <a:effectLst/>
-              <a:uFillTx/>
-              <a:latin typeface="Arial"/>
-            </a:endParaRPr>
-          </a:p>
-        </p:txBody>
-      </p:sp>
-      <p:sp>
-        <p:nvSpPr>
-          <p:cNvPr id="140" name="Shape 47"/>
-          <p:cNvSpPr/>
-          <p:nvPr/>
-        </p:nvSpPr>
-        <p:spPr>
-          <a:xfrm>
-            <a:off x="8121600" y="3927240"/>
-            <a:ext cx="3502800" cy="2234880"/>
-          </a:xfrm>
-          <a:prstGeom prst="roundRect">
-            <a:avLst>
-              <a:gd name="adj" fmla="val 3273"/>
-            </a:avLst>
-          </a:prstGeom>
-          <a:solidFill>
-            <a:srgbClr val="F7E4D8"/>
-          </a:solidFill>
-          <a:ln w="12700">
-            <a:solidFill>
-              <a:srgbClr val="F7E4D8"/>
-            </a:solidFill>
-            <a:round/>
-          </a:ln>
-        </p:spPr>
-        <p:style>
-          <a:lnRef idx="0"/>
-          <a:fillRef idx="0"/>
-          <a:effectRef idx="0"/>
-          <a:fontRef idx="minor"/>
-        </p:style>
-        <p:txBody>
-          <a:bodyPr lIns="90000" tIns="45000" rIns="90000" bIns="45000" anchor="t">
-            <a:noAutofit/>
-          </a:bodyPr>
-          <a:p>
-            <a:endParaRPr lang="en-US" sz="1800" b="0" u="none" strike="noStrike">
-              <a:solidFill>
-                <a:srgbClr val="000000"/>
-              </a:solidFill>
-              <a:effectLst/>
-              <a:uFillTx/>
-              <a:latin typeface="Arial"/>
-            </a:endParaRPr>
-          </a:p>
-        </p:txBody>
-      </p:sp>
-      <p:sp>
-        <p:nvSpPr>
-          <p:cNvPr id="141" name="Text 61"/>
-          <p:cNvSpPr/>
-          <p:nvPr/>
-        </p:nvSpPr>
-        <p:spPr>
-          <a:xfrm>
-            <a:off x="8359560" y="4165200"/>
-            <a:ext cx="3027240" cy="247320"/>
-          </a:xfrm>
-          <a:prstGeom prst="rect">
-            <a:avLst/>
-          </a:prstGeom>
-          <a:noFill/>
-          <a:ln w="0">
-            <a:noFill/>
-          </a:ln>
-        </p:spPr>
-        <p:style>
-          <a:lnRef idx="0"/>
-          <a:fillRef idx="0"/>
-          <a:effectRef idx="0"/>
-          <a:fontRef idx="minor"/>
-        </p:style>
-        <p:txBody>
-          <a:bodyPr lIns="0" tIns="0" rIns="0" bIns="0" anchor="t">
-            <a:noAutofit/>
-          </a:bodyPr>
-          <a:p>
-            <a:pPr defTabSz="914400">
-              <a:lnSpc>
-                <a:spcPct val="100000"/>
-              </a:lnSpc>
-              <a:tabLst>
-                <a:tab pos="0" algn="l"/>
-              </a:tabLst>
-            </a:pPr>
-            <a:r>
-              <a:rPr lang="en-US" sz="1170" b="1" u="none" strike="noStrike">
-                <a:solidFill>
-                  <a:srgbClr val="16262E"/>
-                </a:solidFill>
-                <a:effectLst/>
-                <a:uFillTx/>
-                <a:latin typeface="Arial"/>
-                <a:ea typeface="Arial"/>
-              </a:rPr>
-              <a:t>Y la base de tu proyecto</a:t>
-            </a:r>
-            <a:endParaRPr lang="en-US" sz="1170" b="0" u="none" strike="noStrike">
-              <a:solidFill>
-                <a:srgbClr val="000000"/>
-              </a:solidFill>
-              <a:effectLst/>
-              <a:uFillTx/>
-              <a:latin typeface="Arial"/>
-            </a:endParaRPr>
-          </a:p>
-        </p:txBody>
-      </p:sp>
-      <p:sp>
-        <p:nvSpPr>
-          <p:cNvPr id="142" name="Text 62"/>
-          <p:cNvSpPr/>
-          <p:nvPr/>
-        </p:nvSpPr>
-        <p:spPr>
-          <a:xfrm>
-            <a:off x="8359560" y="4559040"/>
-            <a:ext cx="3027240" cy="1401840"/>
-          </a:xfrm>
-          <a:prstGeom prst="rect">
-            <a:avLst/>
-          </a:prstGeom>
-          <a:noFill/>
-          <a:ln w="0">
-            <a:noFill/>
-          </a:ln>
-        </p:spPr>
-        <p:style>
-          <a:lnRef idx="0"/>
-          <a:fillRef idx="0"/>
-          <a:effectRef idx="0"/>
-          <a:fontRef idx="minor"/>
-        </p:style>
-        <p:txBody>
-          <a:bodyPr lIns="0" tIns="0" rIns="0" bIns="0" anchor="t">
-            <a:noAutofit/>
-          </a:bodyPr>
-          <a:p>
-            <a:pPr defTabSz="914400">
-              <a:lnSpc>
-                <a:spcPct val="110000"/>
-              </a:lnSpc>
-              <a:tabLst>
-                <a:tab pos="0" algn="l"/>
-              </a:tabLst>
-            </a:pPr>
-            <a:r>
-              <a:rPr lang="en-US" sz="950" b="0" u="none" strike="noStrike">
-                <a:solidFill>
-                  <a:srgbClr val="16262E"/>
-                </a:solidFill>
-                <a:effectLst/>
-                <a:uFillTx/>
-                <a:latin typeface="Calibri"/>
-                <a:ea typeface="Calibri"/>
-              </a:rPr>
-              <a:t>El proyecto final vale otro 40 por ciento y se trabaja en equipo. Lo que hagas estas dos semanas puede ser su punto de partida.</a:t>
-            </a:r>
-            <a:endParaRPr lang="en-US" sz="950" b="0" u="none" strike="noStrike">
               <a:solidFill>
                 <a:srgbClr val="000000"/>
               </a:solidFill>

</xml_diff>